<commit_message>
발표 초안: 9장 · 14장 체험 주소 채움 (GitHub Pages part5)
Co-Authored-By: Claude Opus 5.5 <noreply@anthropic.com>
</commit_message>
<xml_diff>
--- a/docs/presentation/M1_presentation_draft_v0.1.pptx
+++ b/docs/presentation/M1_presentation_draft_v0.1.pptx
@@ -6846,7 +6846,7 @@
                 <a:ea typeface="Malgun Gothic" pitchFamily="34" charset="-122"/>
                 <a:cs typeface="Malgun Gothic" pitchFamily="34" charset="-120"/>
               </a:rPr>
-              <a:t>체험  [GitHub Pages 주소]/part5/</a:t>
+              <a:t>체험  ctaleez51-art.github.io/sales-analysis/part5/</a:t>
             </a:r>
             <a:endParaRPr lang="en-US" sz="1500" dirty="0"/>
           </a:p>
@@ -14724,7 +14724,7 @@
                 <a:ea typeface="Malgun Gothic" pitchFamily="34" charset="-122"/>
                 <a:cs typeface="Malgun Gothic" pitchFamily="34" charset="-120"/>
               </a:rPr>
-              <a:t>체험 주소: [GitHub Pages 주소 — 병합 · 설정 뒤 채우기] /part5/</a:t>
+              <a:t>체험 주소: ctaleez51-art.github.io/sales-analysis/part5/</a:t>
             </a:r>
             <a:endParaRPr lang="en-US" sz="1500" dirty="0"/>
           </a:p>

</xml_diff>